<commit_message>
Fase 3+4: risco por area (IA+gestor), gamificacao, feedback educativo, auditabilidade, multi-camera/headless, robustez adaptativa, fusao, modo claro/escuro, ESP low-power
</commit_message>
<xml_diff>
--- a/entregaveis/Pitch_Tortuga_Fase2.pptx
+++ b/entregaveis/Pitch_Tortuga_Fase2.pptx
@@ -301,7 +301,160 @@
           <a:lstStyle/>
           <a:p>
             <a:r>
-              <a:t>HOOK (0:00–0:30). Frase de impacto + identificação. 'Somos o grupo Tortuga. Na Fase 1 o sistema passou a enxergar QUAIS EPIs o trabalhador usa. Na Fase 2 ele passa a entender COMO ele se move e onde — e a prever o risco antes do acidente.' Apresentar os 3 diferenciais do canto.</a:t>
+              <a:rPr dirty="0"/>
+              <a:t>HOOK (0:00–0:30). Frase de </a:t>
+            </a:r>
+            <a:r>
+              <a:rPr dirty="0" err="1"/>
+              <a:t>impacto</a:t>
+            </a:r>
+            <a:r>
+              <a:rPr dirty="0"/>
+              <a:t> + </a:t>
+            </a:r>
+            <a:r>
+              <a:rPr dirty="0" err="1"/>
+              <a:t>identificação</a:t>
+            </a:r>
+            <a:r>
+              <a:rPr dirty="0"/>
+              <a:t>. 'Somos o </a:t>
+            </a:r>
+            <a:r>
+              <a:rPr dirty="0" err="1"/>
+              <a:t>grupo</a:t>
+            </a:r>
+            <a:r>
+              <a:rPr dirty="0"/>
+              <a:t> Tortuga. Na Fase 1 o </a:t>
+            </a:r>
+            <a:r>
+              <a:rPr dirty="0" err="1"/>
+              <a:t>sistema</a:t>
+            </a:r>
+            <a:r>
+              <a:rPr dirty="0"/>
+              <a:t> </a:t>
+            </a:r>
+            <a:r>
+              <a:rPr dirty="0" err="1"/>
+              <a:t>passou</a:t>
+            </a:r>
+            <a:r>
+              <a:rPr dirty="0"/>
+              <a:t> a </a:t>
+            </a:r>
+            <a:r>
+              <a:rPr dirty="0" err="1"/>
+              <a:t>enxergar</a:t>
+            </a:r>
+            <a:r>
+              <a:rPr dirty="0"/>
+              <a:t> QUAIS EPIs o </a:t>
+            </a:r>
+            <a:r>
+              <a:rPr dirty="0" err="1"/>
+              <a:t>trabalhador</a:t>
+            </a:r>
+            <a:r>
+              <a:rPr dirty="0"/>
+              <a:t> </a:t>
+            </a:r>
+            <a:r>
+              <a:rPr dirty="0" err="1"/>
+              <a:t>usa</a:t>
+            </a:r>
+            <a:r>
+              <a:rPr dirty="0"/>
+              <a:t>. Na Fase 2 </a:t>
+            </a:r>
+            <a:r>
+              <a:rPr dirty="0" err="1"/>
+              <a:t>ele</a:t>
+            </a:r>
+            <a:r>
+              <a:rPr dirty="0"/>
+              <a:t> </a:t>
+            </a:r>
+            <a:r>
+              <a:rPr dirty="0" err="1"/>
+              <a:t>passa</a:t>
+            </a:r>
+            <a:r>
+              <a:rPr dirty="0"/>
+              <a:t> a </a:t>
+            </a:r>
+            <a:r>
+              <a:rPr dirty="0" err="1"/>
+              <a:t>entender</a:t>
+            </a:r>
+            <a:r>
+              <a:rPr dirty="0"/>
+              <a:t> COMO </a:t>
+            </a:r>
+            <a:r>
+              <a:rPr dirty="0" err="1"/>
+              <a:t>ele</a:t>
+            </a:r>
+            <a:r>
+              <a:rPr dirty="0"/>
+              <a:t> se move e </a:t>
+            </a:r>
+            <a:r>
+              <a:rPr dirty="0" err="1"/>
+              <a:t>onde</a:t>
+            </a:r>
+            <a:r>
+              <a:rPr dirty="0"/>
+              <a:t> — e a </a:t>
+            </a:r>
+            <a:r>
+              <a:rPr dirty="0" err="1"/>
+              <a:t>prever</a:t>
+            </a:r>
+            <a:r>
+              <a:rPr dirty="0"/>
+              <a:t> o </a:t>
+            </a:r>
+            <a:r>
+              <a:rPr dirty="0" err="1"/>
+              <a:t>risco</a:t>
+            </a:r>
+            <a:r>
+              <a:rPr dirty="0"/>
+              <a:t> antes do </a:t>
+            </a:r>
+            <a:r>
+              <a:rPr dirty="0" err="1"/>
+              <a:t>acidente</a:t>
+            </a:r>
+            <a:r>
+              <a:rPr dirty="0"/>
+              <a:t>.' </a:t>
+            </a:r>
+            <a:r>
+              <a:rPr dirty="0" err="1"/>
+              <a:t>Apresentar</a:t>
+            </a:r>
+            <a:r>
+              <a:rPr dirty="0"/>
+              <a:t> </a:t>
+            </a:r>
+            <a:r>
+              <a:rPr dirty="0" err="1"/>
+              <a:t>os</a:t>
+            </a:r>
+            <a:r>
+              <a:rPr dirty="0"/>
+              <a:t> 3 </a:t>
+            </a:r>
+            <a:r>
+              <a:rPr dirty="0" err="1"/>
+              <a:t>diferenciais</a:t>
+            </a:r>
+            <a:r>
+              <a:rPr dirty="0"/>
+              <a:t> do canto.</a:t>
             </a:r>
           </a:p>
         </p:txBody>
@@ -7457,48 +7610,6 @@
               </a:rPr>
               <a:t>O que a banca vai ver ao vivo</a:t>
             </a:r>
-          </a:p>
-        </p:txBody>
-      </p:sp>
-      <p:sp>
-        <p:nvSpPr>
-          <p:cNvPr id="5" name="TextBox 4"/>
-          <p:cNvSpPr txBox="1"/>
-          <p:nvPr/>
-        </p:nvSpPr>
-        <p:spPr>
-          <a:xfrm>
-            <a:off x="521207" y="932688"/>
-            <a:ext cx="8778240" cy="200055"/>
-          </a:xfrm>
-          <a:prstGeom prst="rect">
-            <a:avLst/>
-          </a:prstGeom>
-          <a:noFill/>
-        </p:spPr>
-        <p:txBody>
-          <a:bodyPr wrap="square" lIns="0" tIns="0" rIns="0" bIns="0" anchor="t">
-            <a:spAutoFit/>
-          </a:bodyPr>
-          <a:lstStyle/>
-          <a:p>
-            <a:pPr algn="l">
-              <a:lnSpc>
-                <a:spcPct val="100000"/>
-              </a:lnSpc>
-              <a:spcBef>
-                <a:spcPts val="0"/>
-              </a:spcBef>
-              <a:spcAft>
-                <a:spcPts val="400"/>
-              </a:spcAft>
-            </a:pPr>
-            <a:endParaRPr sz="1300" b="0" i="0" dirty="0">
-              <a:solidFill>
-                <a:srgbClr val="A7B0BE"/>
-              </a:solidFill>
-              <a:latin typeface="Arial"/>
-            </a:endParaRPr>
           </a:p>
         </p:txBody>
       </p:sp>

</xml_diff>